<commit_message>
chore: remove retired ensemble members (s52, xval-lr1e4), sync presentation files
</commit_message>
<xml_diff>
--- a/ppt/SynCura_PACE_Format_PROFESSIONAL.pptx
+++ b/ppt/SynCura_PACE_Format_PROFESSIONAL.pptx
@@ -4783,7 +4783,7 @@
           <a:p>
             <a:pPr algn="l">
               <a:lnSpc>
-                <a:spcPct val="115000"/>
+                <a:spcPct val="105000"/>
               </a:lnSpc>
               <a:spcAft>
                 <a:spcPts val="300"/>
@@ -4791,18 +4791,15 @@
             </a:pPr>
             <a:r>
               <a:rPr sz="1500">
-                <a:solidFill>
-                  <a:srgbClr val="1F2937"/>
-                </a:solidFill>
-                <a:latin typeface="Times New Roman"/>
-              </a:rPr>
-              <a:t>[1] Wang, Bai and Jin, Frontiers in Physiology, 2026.</a:t>
-            </a:r>
-          </a:p>
-          <a:p>
-            <a:pPr algn="l">
+                <a:latin typeface="Times New Roman"/>
+              </a:rPr>
+              <a:t>[1] Zheng et al., Journal of Medical Internet Research, vol. 27, e69293, 2025.</a:t>
+            </a:r>
+          </a:p>
+          <a:p>
+            <a:pPr>
               <a:lnSpc>
-                <a:spcPct val="115000"/>
+                <a:spcPct val="105000"/>
               </a:lnSpc>
               <a:spcAft>
                 <a:spcPts val="300"/>
@@ -4810,18 +4807,15 @@
             </a:pPr>
             <a:r>
               <a:rPr sz="1500">
-                <a:solidFill>
-                  <a:srgbClr val="1F2937"/>
-                </a:solidFill>
                 <a:latin typeface="Times New Roman"/>
               </a:rPr>
               <a:t>[2] Yan et al., PeerJ, vol. 14, e21631, 2026.</a:t>
             </a:r>
           </a:p>
           <a:p>
-            <a:pPr algn="l">
+            <a:pPr>
               <a:lnSpc>
-                <a:spcPct val="115000"/>
+                <a:spcPct val="105000"/>
               </a:lnSpc>
               <a:spcAft>
                 <a:spcPts val="300"/>
@@ -4829,18 +4823,15 @@
             </a:pPr>
             <a:r>
               <a:rPr sz="1500">
-                <a:solidFill>
-                  <a:srgbClr val="1F2937"/>
-                </a:solidFill>
                 <a:latin typeface="Times New Roman"/>
               </a:rPr>
               <a:t>[3] Sadanandan, arXiv:2603.14719, 2026.</a:t>
             </a:r>
           </a:p>
           <a:p>
-            <a:pPr algn="l">
+            <a:pPr>
               <a:lnSpc>
-                <a:spcPct val="115000"/>
+                <a:spcPct val="105000"/>
               </a:lnSpc>
               <a:spcAft>
                 <a:spcPts val="300"/>
@@ -4848,18 +4839,15 @@
             </a:pPr>
             <a:r>
               <a:rPr sz="1500">
-                <a:solidFill>
-                  <a:srgbClr val="1F2937"/>
-                </a:solidFill>
                 <a:latin typeface="Times New Roman"/>
               </a:rPr>
               <a:t>[4] Wu et al., Journal of Big Data, vol. 11, no. 40, 2024.</a:t>
             </a:r>
           </a:p>
           <a:p>
-            <a:pPr algn="l">
+            <a:pPr>
               <a:lnSpc>
-                <a:spcPct val="115000"/>
+                <a:spcPct val="105000"/>
               </a:lnSpc>
               <a:spcAft>
                 <a:spcPts val="300"/>
@@ -4867,9 +4855,6 @@
             </a:pPr>
             <a:r>
               <a:rPr sz="1500">
-                <a:solidFill>
-                  <a:srgbClr val="1F2937"/>
-                </a:solidFill>
                 <a:latin typeface="Times New Roman"/>
               </a:rPr>
               <a:t>[5] Nguyen et al., arXiv:1707.05010, 2017.</a:t>
@@ -7704,39 +7689,33 @@
           <a:p>
             <a:pPr algn="l">
               <a:lnSpc>
-                <a:spcPct val="115000"/>
+                <a:spcPct val="105000"/>
               </a:lnSpc>
               <a:spcAft>
                 <a:spcPts val="300"/>
               </a:spcAft>
             </a:pPr>
             <a:r>
-              <a:rPr sz="1400">
-                <a:solidFill>
-                  <a:srgbClr val="1F2937"/>
-                </a:solidFill>
-                <a:latin typeface="Times New Roman"/>
-              </a:rPr>
-              <a:t>Explainable Deep-Learning Models to Predict Diaphragmatic Dysfunction and Cognitive Stress in ICU Patients Under Mechanical Ventilation</a:t>
-            </a:r>
-          </a:p>
-          <a:p>
-            <a:pPr algn="l">
+              <a:rPr sz="1100">
+                <a:latin typeface="Times New Roman"/>
+              </a:rPr>
+              <a:t>Development and Validation of a Dynamic Real-Time Risk Prediction Model for ICU Patients Based on Longitudinal Irregular Data: Multicenter Retrospective Study</a:t>
+            </a:r>
+          </a:p>
+          <a:p>
+            <a:pPr>
               <a:lnSpc>
-                <a:spcPct val="115000"/>
+                <a:spcPct val="105000"/>
               </a:lnSpc>
               <a:spcAft>
                 <a:spcPts val="300"/>
               </a:spcAft>
             </a:pPr>
             <a:r>
-              <a:rPr sz="1400">
-                <a:solidFill>
-                  <a:srgbClr val="1F2937"/>
-                </a:solidFill>
-                <a:latin typeface="Times New Roman"/>
-              </a:rPr>
-              <a:t>Wang, Y., Bai, Y., and Jin, G. | 2026 | Frontiers in Physiology, vol. 17, Art. no. 1765898</a:t>
+              <a:rPr sz="1100">
+                <a:latin typeface="Times New Roman"/>
+              </a:rPr>
+              <a:t>Zheng, Z., Luo, J., Zhu, Y., Du, L., Lan, L., Zhou, X., Yang, X., and Huang, S. | 2025 | Journal of Medical Internet Research, vol. 27, e69293</a:t>
             </a:r>
           </a:p>
         </p:txBody>
@@ -7845,58 +7824,49 @@
           <a:p>
             <a:pPr algn="l">
               <a:lnSpc>
-                <a:spcPct val="115000"/>
+                <a:spcPct val="105000"/>
               </a:lnSpc>
               <a:spcAft>
                 <a:spcPts val="300"/>
               </a:spcAft>
             </a:pPr>
             <a:r>
-              <a:rPr sz="1400">
-                <a:solidFill>
-                  <a:srgbClr val="1F2937"/>
-                </a:solidFill>
-                <a:latin typeface="Times New Roman"/>
-              </a:rPr>
-              <a:t>25,751 mechanically ventilated ICU patients.</a:t>
-            </a:r>
-          </a:p>
-          <a:p>
-            <a:pPr algn="l">
+              <a:rPr sz="1200">
+                <a:latin typeface="Times New Roman"/>
+              </a:rPr>
+              <a:t>176,344 ICU stays from MIMIC-IV and eICU-CRD.</a:t>
+            </a:r>
+          </a:p>
+          <a:p>
+            <a:pPr>
               <a:lnSpc>
-                <a:spcPct val="115000"/>
+                <a:spcPct val="105000"/>
               </a:lnSpc>
               <a:spcAft>
                 <a:spcPts val="300"/>
               </a:spcAft>
             </a:pPr>
             <a:r>
-              <a:rPr sz="1400">
-                <a:solidFill>
-                  <a:srgbClr val="1F2937"/>
-                </a:solidFill>
-                <a:latin typeface="Times New Roman"/>
-              </a:rPr>
-              <a:t>Continuous vital and ventilator time-series.</a:t>
-            </a:r>
-          </a:p>
-          <a:p>
-            <a:pPr algn="l">
+              <a:rPr sz="1200">
+                <a:latin typeface="Times New Roman"/>
+              </a:rPr>
+              <a:t>Irregular longitudinal EMR: vitals, labs, and medications with hourly updates.</a:t>
+            </a:r>
+          </a:p>
+          <a:p>
+            <a:pPr>
               <a:lnSpc>
-                <a:spcPct val="115000"/>
+                <a:spcPct val="105000"/>
               </a:lnSpc>
               <a:spcAft>
                 <a:spcPts val="300"/>
               </a:spcAft>
             </a:pPr>
             <a:r>
-              <a:rPr sz="1400">
-                <a:solidFill>
-                  <a:srgbClr val="1F2937"/>
-                </a:solidFill>
-                <a:latin typeface="Times New Roman"/>
-              </a:rPr>
-              <a:t>Compared LSTM, GRU, and RNN models.</a:t>
+              <a:rPr sz="1200">
+                <a:latin typeface="Times New Roman"/>
+              </a:rPr>
+              <a:t>Time-aware bidirectional attention LSTM (TBAL).</a:t>
             </a:r>
           </a:p>
         </p:txBody>
@@ -8005,58 +7975,49 @@
           <a:p>
             <a:pPr algn="l">
               <a:lnSpc>
-                <a:spcPct val="115000"/>
+                <a:spcPct val="105000"/>
               </a:lnSpc>
               <a:spcAft>
                 <a:spcPts val="300"/>
               </a:spcAft>
             </a:pPr>
             <a:r>
-              <a:rPr sz="1400">
-                <a:solidFill>
-                  <a:srgbClr val="1F2937"/>
-                </a:solidFill>
-                <a:latin typeface="Times New Roman"/>
-              </a:rPr>
-              <a:t>LSTM performed consistently well.</a:t>
-            </a:r>
-          </a:p>
-          <a:p>
-            <a:pPr algn="l">
+              <a:rPr sz="1200">
+                <a:latin typeface="Times New Roman"/>
+              </a:rPr>
+              <a:t>Dynamic AUROC 0.936 on MIMIC-IV.</a:t>
+            </a:r>
+          </a:p>
+          <a:p>
+            <a:pPr>
               <a:lnSpc>
-                <a:spcPct val="115000"/>
+                <a:spcPct val="105000"/>
               </a:lnSpc>
               <a:spcAft>
                 <a:spcPts val="300"/>
               </a:spcAft>
             </a:pPr>
             <a:r>
-              <a:rPr sz="1400">
-                <a:solidFill>
-                  <a:srgbClr val="1F2937"/>
-                </a:solidFill>
-                <a:latin typeface="Times New Roman"/>
-              </a:rPr>
-              <a:t>Reported AUC range: about 0.79-0.87.</a:t>
-            </a:r>
-          </a:p>
-          <a:p>
-            <a:pPr algn="l">
+              <a:rPr sz="1200">
+                <a:latin typeface="Times New Roman"/>
+              </a:rPr>
+              <a:t>External eICU AUROC 0.919 with recall of 79.1%.</a:t>
+            </a:r>
+          </a:p>
+          <a:p>
+            <a:pPr>
               <a:lnSpc>
-                <a:spcPct val="115000"/>
+                <a:spcPct val="105000"/>
               </a:lnSpc>
               <a:spcAft>
                 <a:spcPts val="300"/>
               </a:spcAft>
             </a:pPr>
             <a:r>
-              <a:rPr sz="1400">
-                <a:solidFill>
-                  <a:srgbClr val="1F2937"/>
-                </a:solidFill>
-                <a:latin typeface="Times New Roman"/>
-              </a:rPr>
-              <a:t>Explainability is emphasized for clinical trust.</a:t>
+              <a:rPr sz="1200">
+                <a:latin typeface="Times New Roman"/>
+              </a:rPr>
+              <a:t>Attention and Integrated Gradients support interpretation.</a:t>
             </a:r>
           </a:p>
         </p:txBody>
@@ -8165,39 +8126,33 @@
           <a:p>
             <a:pPr algn="l">
               <a:lnSpc>
-                <a:spcPct val="115000"/>
+                <a:spcPct val="105000"/>
               </a:lnSpc>
               <a:spcAft>
                 <a:spcPts val="300"/>
               </a:spcAft>
             </a:pPr>
             <a:r>
-              <a:rPr sz="1300">
-                <a:solidFill>
-                  <a:srgbClr val="1F2937"/>
-                </a:solidFill>
-                <a:latin typeface="Times New Roman"/>
-              </a:rPr>
-              <a:t>Time-series signals were not equally strong for every outcome.</a:t>
-            </a:r>
-          </a:p>
-          <a:p>
-            <a:pPr algn="l">
+              <a:rPr sz="1100">
+                <a:latin typeface="Times New Roman"/>
+              </a:rPr>
+              <a:t>Uses richer EMR and much larger multicenter data than SynCura.</a:t>
+            </a:r>
+          </a:p>
+          <a:p>
+            <a:pPr>
               <a:lnSpc>
-                <a:spcPct val="115000"/>
+                <a:spcPct val="105000"/>
               </a:lnSpc>
               <a:spcAft>
                 <a:spcPts val="300"/>
               </a:spcAft>
             </a:pPr>
             <a:r>
-              <a:rPr sz="1300">
-                <a:solidFill>
-                  <a:srgbClr val="1F2937"/>
-                </a:solidFill>
-                <a:latin typeface="Times New Roman"/>
-              </a:rPr>
-              <a:t>SynCura adapts the LSTM idea to PhysioNet 2012 and adds temporal attention plus deployment.</a:t>
+              <a:rPr sz="1100">
+                <a:latin typeface="Times New Roman"/>
+              </a:rPr>
+              <a:t>SynCura adapts the attention-LSTM design to PhysioNet 2012 with 12 features and adds SHAP explanations.</a:t>
             </a:r>
           </a:p>
         </p:txBody>

</xml_diff>